<commit_message>
Update README and slides to the final 14 Oct data snapshot
</commit_message>
<xml_diff>
--- a/Term 1/Week 6/hackathon/Hackathon6_slides.pptx
+++ b/Term 1/Week 6/hackathon/Hackathon6_slides.pptx
@@ -154,19 +154,19 @@
               <c:strCache>
                 <c:ptCount val="5"/>
                 <c:pt idx="0">
-                  <c:v>Delays and cancellations (157)</c:v>
+                  <c:v>Delays and cancellations (212)</c:v>
                 </c:pt>
                 <c:pt idx="1">
-                  <c:v>App and tickets (61)</c:v>
+                  <c:v>App and tickets (81)</c:v>
                 </c:pt>
                 <c:pt idx="2">
-                  <c:v>On-board experience (31)</c:v>
+                  <c:v>On-board experience (39)</c:v>
                 </c:pt>
                 <c:pt idx="3">
-                  <c:v>Construction (53)</c:v>
+                  <c:v>Construction (67)</c:v>
                 </c:pt>
                 <c:pt idx="4">
-                  <c:v>Other (326)</c:v>
+                  <c:v>Other (455)</c:v>
                 </c:pt>
               </c:strCache>
             </c:strRef>
@@ -184,13 +184,13 @@
                   <c:v>44</c:v>
                 </c:pt>
                 <c:pt idx="2">
-                  <c:v>39</c:v>
+                  <c:v>41</c:v>
                 </c:pt>
                 <c:pt idx="3">
-                  <c:v>28</c:v>
+                  <c:v>33</c:v>
                 </c:pt>
                 <c:pt idx="4">
-                  <c:v>30</c:v>
+                  <c:v>31</c:v>
                 </c:pt>
               </c:numCache>
             </c:numRef>
@@ -5769,7 +5769,7 @@
                 </a:solidFill>
                 <a:latin typeface="Calibri"/>
               </a:rPr>
-              <a:t>Share of negative posts by topic (personal posts, Model 2, snapshot 13 Oct)</a:t>
+              <a:t>Share of negative posts by topic (personal posts, Model 2, snapshot 14 Oct)</a:t>
             </a:r>
           </a:p>
         </p:txBody>
@@ -5826,7 +5826,7 @@
                 </a:solidFill>
                 <a:latin typeface="Calibri"/>
               </a:rPr>
-              <a:t>•  641 posts (586 personal, 55 news), 162 collector runs, all successful.</a:t>
+              <a:t>•  885 posts (803 personal, 82 news), 303 collector runs, all successful, over 50 hours.</a:t>
             </a:r>
           </a:p>
           <a:p>
@@ -5842,7 +5842,7 @@
                 </a:solidFill>
                 <a:latin typeface="Calibri"/>
               </a:rPr>
-              <a:t>•  Delays are the most negative topic: 55%, against 38% across all personal posts.</a:t>
+              <a:t>•  Delays are the most negative topic: 55%, against 39% across all personal posts.</a:t>
             </a:r>
           </a:p>
           <a:p>
@@ -5858,7 +5858,7 @@
                 </a:solidFill>
                 <a:latin typeface="Calibri"/>
               </a:rPr>
-              <a:t>•  Construction is only 28%: mostly neutral notices about closures and replacement buses.</a:t>
+              <a:t>•  Construction is only 33%: mostly neutral notices about closures and replacement buses.</a:t>
             </a:r>
           </a:p>
           <a:p>

</xml_diff>